<commit_message>
Add agent expanded view to AGI slide with logos and YouTube demos
Slide 12 now has a two-page crossfade system: page 1 shows the existing
AGI meter + Kurzweil chart, page 2 (on next arrow) reveals agent definition
(plan/reason, tools, memory) with 5 agent category cards featuring real
company favicon logos and YouTube play buttons that open popup windows.
16 company logos added to screenshots/logos/. PROJECT-STATE.md updated.

Co-Authored-By: Claude Opus 4.6 <noreply@anthropic.com>
</commit_message>
<xml_diff>
--- a/iisc-talk-deck.pptx
+++ b/iisc-talk-deck.pptx
@@ -6320,7 +6320,7 @@
         </p:nvSpPr>
         <p:spPr>
           <a:xfrm>
-            <a:off x="457200" y="457200"/>
+            <a:off x="457200" y="274320"/>
             <a:ext cx="11277295" cy="640080"/>
           </a:xfrm>
           <a:prstGeom prst="rect">
@@ -6343,20 +6343,56 @@
               </a:defRPr>
             </a:pPr>
             <a:r>
-              <a:t>What is an agent?</a:t>
-            </a:r>
-          </a:p>
-        </p:txBody>
-      </p:sp>
-      <p:sp>
-        <p:nvSpPr>
-          <p:cNvPr id="3" name="Rectangle 2"/>
+              <a:t>Level 3: Agents</a:t>
+            </a:r>
+          </a:p>
+        </p:txBody>
+      </p:sp>
+      <p:sp>
+        <p:nvSpPr>
+          <p:cNvPr id="3" name="TextBox 2"/>
+          <p:cNvSpPr txBox="1"/>
+          <p:nvPr/>
+        </p:nvSpPr>
+        <p:spPr>
+          <a:xfrm>
+            <a:off x="457200" y="777240"/>
+            <a:ext cx="3657600" cy="274320"/>
+          </a:xfrm>
+          <a:prstGeom prst="rect">
+            <a:avLst/>
+          </a:prstGeom>
+          <a:noFill/>
+        </p:spPr>
+        <p:txBody>
+          <a:bodyPr wrap="square">
+            <a:spAutoFit/>
+          </a:bodyPr>
+          <a:lstStyle/>
+          <a:p>
+            <a:pPr algn="l">
+              <a:defRPr sz="1600" b="1">
+                <a:solidFill>
+                  <a:srgbClr val="FFB900"/>
+                </a:solidFill>
+                <a:latin typeface="Segoe UI"/>
+              </a:defRPr>
+            </a:pPr>
+            <a:r>
+              <a:t>We are here, 2025</a:t>
+            </a:r>
+          </a:p>
+        </p:txBody>
+      </p:sp>
+      <p:sp>
+        <p:nvSpPr>
+          <p:cNvPr id="4" name="Rectangle 3"/>
           <p:cNvSpPr/>
           <p:nvPr/>
         </p:nvSpPr>
         <p:spPr>
           <a:xfrm>
-            <a:off x="457200" y="1188720"/>
+            <a:off x="457200" y="1097280"/>
             <a:ext cx="4572000" cy="36576"/>
           </a:xfrm>
           <a:prstGeom prst="rect">
@@ -6393,31 +6429,64 @@
       </p:sp>
       <p:sp>
         <p:nvSpPr>
-          <p:cNvPr id="4" name="TextBox 3"/>
-          <p:cNvSpPr txBox="1"/>
-          <p:nvPr/>
-        </p:nvSpPr>
-        <p:spPr>
-          <a:xfrm>
-            <a:off x="914400" y="1828800"/>
-            <a:ext cx="10058400" cy="1097280"/>
-          </a:xfrm>
-          <a:prstGeom prst="rect">
-            <a:avLst/>
-          </a:prstGeom>
-          <a:noFill/>
-        </p:spPr>
-        <p:txBody>
-          <a:bodyPr wrap="square">
-            <a:spAutoFit/>
-          </a:bodyPr>
-          <a:lstStyle/>
-          <a:p>
-            <a:pPr algn="ctr">
-              <a:spcAft>
-                <a:spcPts val="1000"/>
-              </a:spcAft>
-              <a:defRPr sz="2600" b="0">
+          <p:cNvPr id="5" name="TextBox 4"/>
+          <p:cNvSpPr txBox="1"/>
+          <p:nvPr/>
+        </p:nvSpPr>
+        <p:spPr>
+          <a:xfrm>
+            <a:off x="457200" y="1371600"/>
+            <a:ext cx="5029200" cy="457200"/>
+          </a:xfrm>
+          <a:prstGeom prst="rect">
+            <a:avLst/>
+          </a:prstGeom>
+          <a:noFill/>
+        </p:spPr>
+        <p:txBody>
+          <a:bodyPr wrap="square">
+            <a:spAutoFit/>
+          </a:bodyPr>
+          <a:lstStyle/>
+          <a:p>
+            <a:pPr algn="l">
+              <a:defRPr sz="2000" b="1">
+                <a:solidFill>
+                  <a:srgbClr val="0F6CBD"/>
+                </a:solidFill>
+                <a:latin typeface="Segoe UI"/>
+              </a:defRPr>
+            </a:pPr>
+            <a:r>
+              <a:t>What is an agent?</a:t>
+            </a:r>
+          </a:p>
+        </p:txBody>
+      </p:sp>
+      <p:sp>
+        <p:nvSpPr>
+          <p:cNvPr id="6" name="TextBox 5"/>
+          <p:cNvSpPr txBox="1"/>
+          <p:nvPr/>
+        </p:nvSpPr>
+        <p:spPr>
+          <a:xfrm>
+            <a:off x="457200" y="1828800"/>
+            <a:ext cx="5029200" cy="548640"/>
+          </a:xfrm>
+          <a:prstGeom prst="rect">
+            <a:avLst/>
+          </a:prstGeom>
+          <a:noFill/>
+        </p:spPr>
+        <p:txBody>
+          <a:bodyPr wrap="square">
+            <a:spAutoFit/>
+          </a:bodyPr>
+          <a:lstStyle/>
+          <a:p>
+            <a:pPr algn="l">
+              <a:defRPr sz="1600" b="0">
                 <a:solidFill>
                   <a:srgbClr val="FFFFFF"/>
                 </a:solidFill>
@@ -6425,55 +6494,66 @@
               </a:defRPr>
             </a:pPr>
             <a:r>
-              <a:t>A system that can pursue a goal repeatedly</a:t>
-            </a:r>
-          </a:p>
-          <a:p>
-            <a:pPr algn="ctr">
-              <a:spcAft>
-                <a:spcPts val="1000"/>
-              </a:spcAft>
-              <a:defRPr sz="2600" b="0">
-                <a:solidFill>
-                  <a:srgbClr val="FFFFFF"/>
-                </a:solidFill>
-                <a:latin typeface="Segoe UI"/>
-              </a:defRPr>
-            </a:pPr>
-            <a:r>
-              <a:t>by reasoning, planning, using tools to act,</a:t>
-            </a:r>
-          </a:p>
-          <a:p>
-            <a:pPr algn="ctr">
-              <a:spcAft>
-                <a:spcPts val="1000"/>
-              </a:spcAft>
-              <a:defRPr sz="2600" b="0">
-                <a:solidFill>
-                  <a:srgbClr val="FFFFFF"/>
-                </a:solidFill>
-                <a:latin typeface="Segoe UI"/>
-              </a:defRPr>
-            </a:pPr>
-            <a:r>
-              <a:t>and learning from memory and context.</a:t>
-            </a:r>
-          </a:p>
-        </p:txBody>
-      </p:sp>
-      <p:sp>
-        <p:nvSpPr>
-          <p:cNvPr id="5" name="Rounded Rectangle 4"/>
+              <a:t>A system that repeatedly pursues a goal by:</a:t>
+            </a:r>
+          </a:p>
+        </p:txBody>
+      </p:sp>
+      <p:sp>
+        <p:nvSpPr>
+          <p:cNvPr id="7" name="Rounded Rectangle 6"/>
           <p:cNvSpPr/>
           <p:nvPr/>
         </p:nvSpPr>
         <p:spPr>
           <a:xfrm>
-            <a:off x="1097280" y="3840480"/>
-            <a:ext cx="1371600" cy="548640"/>
+            <a:off x="640080" y="2468880"/>
+            <a:ext cx="4663440" cy="777240"/>
           </a:xfrm>
           <a:prstGeom prst="roundRect">
+            <a:avLst/>
+          </a:prstGeom>
+          <a:solidFill>
+            <a:srgbClr val="1B2838"/>
+          </a:solidFill>
+          <a:ln>
+            <a:noFill/>
+          </a:ln>
+        </p:spPr>
+        <p:style>
+          <a:lnRef idx="1">
+            <a:schemeClr val="accent1"/>
+          </a:lnRef>
+          <a:fillRef idx="3">
+            <a:schemeClr val="accent1"/>
+          </a:fillRef>
+          <a:effectRef idx="2">
+            <a:schemeClr val="accent1"/>
+          </a:effectRef>
+          <a:fontRef idx="minor">
+            <a:schemeClr val="lt1"/>
+          </a:fontRef>
+        </p:style>
+        <p:txBody>
+          <a:bodyPr rtlCol="0" anchor="ctr"/>
+          <a:lstStyle/>
+          <a:p>
+            <a:pPr algn="ctr"/>
+          </a:p>
+        </p:txBody>
+      </p:sp>
+      <p:sp>
+        <p:nvSpPr>
+          <p:cNvPr id="8" name="Rectangle 7"/>
+          <p:cNvSpPr/>
+          <p:nvPr/>
+        </p:nvSpPr>
+        <p:spPr>
+          <a:xfrm>
+            <a:off x="640080" y="2468880"/>
+            <a:ext cx="54864" cy="777240"/>
+          </a:xfrm>
+          <a:prstGeom prst="rect">
             <a:avLst/>
           </a:prstGeom>
           <a:solidFill>
@@ -6507,64 +6587,64 @@
       </p:sp>
       <p:sp>
         <p:nvSpPr>
-          <p:cNvPr id="6" name="TextBox 5"/>
-          <p:cNvSpPr txBox="1"/>
-          <p:nvPr/>
-        </p:nvSpPr>
-        <p:spPr>
-          <a:xfrm>
-            <a:off x="1097280" y="3886200"/>
-            <a:ext cx="1371600" cy="457200"/>
-          </a:xfrm>
-          <a:prstGeom prst="rect">
-            <a:avLst/>
-          </a:prstGeom>
-          <a:noFill/>
-        </p:spPr>
-        <p:txBody>
-          <a:bodyPr wrap="square">
-            <a:spAutoFit/>
-          </a:bodyPr>
-          <a:lstStyle/>
-          <a:p>
-            <a:pPr algn="ctr">
-              <a:defRPr sz="1400" b="1">
-                <a:solidFill>
-                  <a:srgbClr val="FFFFFF"/>
-                </a:solidFill>
-                <a:latin typeface="Segoe UI"/>
-              </a:defRPr>
-            </a:pPr>
-            <a:r>
-              <a:t>Signal</a:t>
-            </a:r>
-          </a:p>
-        </p:txBody>
-      </p:sp>
-      <p:sp>
-        <p:nvSpPr>
-          <p:cNvPr id="7" name="TextBox 6"/>
-          <p:cNvSpPr txBox="1"/>
-          <p:nvPr/>
-        </p:nvSpPr>
-        <p:spPr>
-          <a:xfrm>
-            <a:off x="2468880" y="3886200"/>
-            <a:ext cx="365760" cy="457200"/>
-          </a:xfrm>
-          <a:prstGeom prst="rect">
-            <a:avLst/>
-          </a:prstGeom>
-          <a:noFill/>
-        </p:spPr>
-        <p:txBody>
-          <a:bodyPr wrap="square">
-            <a:spAutoFit/>
-          </a:bodyPr>
-          <a:lstStyle/>
-          <a:p>
-            <a:pPr algn="ctr">
-              <a:defRPr sz="2000" b="0">
+          <p:cNvPr id="9" name="TextBox 8"/>
+          <p:cNvSpPr txBox="1"/>
+          <p:nvPr/>
+        </p:nvSpPr>
+        <p:spPr>
+          <a:xfrm>
+            <a:off x="868680" y="2542032"/>
+            <a:ext cx="4297680" cy="320040"/>
+          </a:xfrm>
+          <a:prstGeom prst="rect">
+            <a:avLst/>
+          </a:prstGeom>
+          <a:noFill/>
+        </p:spPr>
+        <p:txBody>
+          <a:bodyPr wrap="square">
+            <a:spAutoFit/>
+          </a:bodyPr>
+          <a:lstStyle/>
+          <a:p>
+            <a:pPr algn="l">
+              <a:defRPr sz="1600" b="1">
+                <a:solidFill>
+                  <a:srgbClr val="0F6CBD"/>
+                </a:solidFill>
+                <a:latin typeface="Segoe UI"/>
+              </a:defRPr>
+            </a:pPr>
+            <a:r>
+              <a:t>i)  Planning and reasoning</a:t>
+            </a:r>
+          </a:p>
+        </p:txBody>
+      </p:sp>
+      <p:sp>
+        <p:nvSpPr>
+          <p:cNvPr id="10" name="TextBox 9"/>
+          <p:cNvSpPr txBox="1"/>
+          <p:nvPr/>
+        </p:nvSpPr>
+        <p:spPr>
+          <a:xfrm>
+            <a:off x="868680" y="2880360"/>
+            <a:ext cx="4297680" cy="320040"/>
+          </a:xfrm>
+          <a:prstGeom prst="rect">
+            <a:avLst/>
+          </a:prstGeom>
+          <a:noFill/>
+        </p:spPr>
+        <p:txBody>
+          <a:bodyPr wrap="square">
+            <a:spAutoFit/>
+          </a:bodyPr>
+          <a:lstStyle/>
+          <a:p>
+            <a:pPr algn="l">
+              <a:defRPr sz="1300" b="0">
                 <a:solidFill>
                   <a:srgbClr val="B0BEC5"/>
                 </a:solidFill>
@@ -6572,23 +6652,66 @@
               </a:defRPr>
             </a:pPr>
             <a:r>
-              <a:t>→</a:t>
-            </a:r>
-          </a:p>
-        </p:txBody>
-      </p:sp>
-      <p:sp>
-        <p:nvSpPr>
-          <p:cNvPr id="8" name="Rounded Rectangle 7"/>
+              <a:t>Break down complex goals into steps</a:t>
+            </a:r>
+          </a:p>
+        </p:txBody>
+      </p:sp>
+      <p:sp>
+        <p:nvSpPr>
+          <p:cNvPr id="11" name="Rounded Rectangle 10"/>
           <p:cNvSpPr/>
           <p:nvPr/>
         </p:nvSpPr>
         <p:spPr>
           <a:xfrm>
-            <a:off x="2834639" y="3840480"/>
-            <a:ext cx="1371600" cy="548640"/>
+            <a:off x="640080" y="3383280"/>
+            <a:ext cx="4663440" cy="777240"/>
           </a:xfrm>
           <a:prstGeom prst="roundRect">
+            <a:avLst/>
+          </a:prstGeom>
+          <a:solidFill>
+            <a:srgbClr val="1B2838"/>
+          </a:solidFill>
+          <a:ln>
+            <a:noFill/>
+          </a:ln>
+        </p:spPr>
+        <p:style>
+          <a:lnRef idx="1">
+            <a:schemeClr val="accent1"/>
+          </a:lnRef>
+          <a:fillRef idx="3">
+            <a:schemeClr val="accent1"/>
+          </a:fillRef>
+          <a:effectRef idx="2">
+            <a:schemeClr val="accent1"/>
+          </a:effectRef>
+          <a:fontRef idx="minor">
+            <a:schemeClr val="lt1"/>
+          </a:fontRef>
+        </p:style>
+        <p:txBody>
+          <a:bodyPr rtlCol="0" anchor="ctr"/>
+          <a:lstStyle/>
+          <a:p>
+            <a:pPr algn="ctr"/>
+          </a:p>
+        </p:txBody>
+      </p:sp>
+      <p:sp>
+        <p:nvSpPr>
+          <p:cNvPr id="12" name="Rectangle 11"/>
+          <p:cNvSpPr/>
+          <p:nvPr/>
+        </p:nvSpPr>
+        <p:spPr>
+          <a:xfrm>
+            <a:off x="640080" y="3383280"/>
+            <a:ext cx="54864" cy="777240"/>
+          </a:xfrm>
+          <a:prstGeom prst="rect">
             <a:avLst/>
           </a:prstGeom>
           <a:solidFill>
@@ -6622,64 +6745,64 @@
       </p:sp>
       <p:sp>
         <p:nvSpPr>
-          <p:cNvPr id="9" name="TextBox 8"/>
-          <p:cNvSpPr txBox="1"/>
-          <p:nvPr/>
-        </p:nvSpPr>
-        <p:spPr>
-          <a:xfrm>
-            <a:off x="2834639" y="3886200"/>
-            <a:ext cx="1371600" cy="457200"/>
-          </a:xfrm>
-          <a:prstGeom prst="rect">
-            <a:avLst/>
-          </a:prstGeom>
-          <a:noFill/>
-        </p:spPr>
-        <p:txBody>
-          <a:bodyPr wrap="square">
-            <a:spAutoFit/>
-          </a:bodyPr>
-          <a:lstStyle/>
-          <a:p>
-            <a:pPr algn="ctr">
-              <a:defRPr sz="1400" b="1">
-                <a:solidFill>
-                  <a:srgbClr val="FFFFFF"/>
-                </a:solidFill>
-                <a:latin typeface="Segoe UI"/>
-              </a:defRPr>
-            </a:pPr>
-            <a:r>
-              <a:t>Understand</a:t>
-            </a:r>
-          </a:p>
-        </p:txBody>
-      </p:sp>
-      <p:sp>
-        <p:nvSpPr>
-          <p:cNvPr id="10" name="TextBox 9"/>
-          <p:cNvSpPr txBox="1"/>
-          <p:nvPr/>
-        </p:nvSpPr>
-        <p:spPr>
-          <a:xfrm>
-            <a:off x="4206240" y="3886200"/>
-            <a:ext cx="365760" cy="457200"/>
-          </a:xfrm>
-          <a:prstGeom prst="rect">
-            <a:avLst/>
-          </a:prstGeom>
-          <a:noFill/>
-        </p:spPr>
-        <p:txBody>
-          <a:bodyPr wrap="square">
-            <a:spAutoFit/>
-          </a:bodyPr>
-          <a:lstStyle/>
-          <a:p>
-            <a:pPr algn="ctr">
-              <a:defRPr sz="2000" b="0">
+          <p:cNvPr id="13" name="TextBox 12"/>
+          <p:cNvSpPr txBox="1"/>
+          <p:nvPr/>
+        </p:nvSpPr>
+        <p:spPr>
+          <a:xfrm>
+            <a:off x="868680" y="3456432"/>
+            <a:ext cx="4297680" cy="320040"/>
+          </a:xfrm>
+          <a:prstGeom prst="rect">
+            <a:avLst/>
+          </a:prstGeom>
+          <a:noFill/>
+        </p:spPr>
+        <p:txBody>
+          <a:bodyPr wrap="square">
+            <a:spAutoFit/>
+          </a:bodyPr>
+          <a:lstStyle/>
+          <a:p>
+            <a:pPr algn="l">
+              <a:defRPr sz="1600" b="1">
+                <a:solidFill>
+                  <a:srgbClr val="00B7C3"/>
+                </a:solidFill>
+                <a:latin typeface="Segoe UI"/>
+              </a:defRPr>
+            </a:pPr>
+            <a:r>
+              <a:t>ii)  Acting on the environment</a:t>
+            </a:r>
+          </a:p>
+        </p:txBody>
+      </p:sp>
+      <p:sp>
+        <p:nvSpPr>
+          <p:cNvPr id="14" name="TextBox 13"/>
+          <p:cNvSpPr txBox="1"/>
+          <p:nvPr/>
+        </p:nvSpPr>
+        <p:spPr>
+          <a:xfrm>
+            <a:off x="868680" y="3794760"/>
+            <a:ext cx="4297680" cy="320040"/>
+          </a:xfrm>
+          <a:prstGeom prst="rect">
+            <a:avLst/>
+          </a:prstGeom>
+          <a:noFill/>
+        </p:spPr>
+        <p:txBody>
+          <a:bodyPr wrap="square">
+            <a:spAutoFit/>
+          </a:bodyPr>
+          <a:lstStyle/>
+          <a:p>
+            <a:pPr algn="l">
+              <a:defRPr sz="1300" b="0">
                 <a:solidFill>
                   <a:srgbClr val="B0BEC5"/>
                 </a:solidFill>
@@ -6687,23 +6810,66 @@
               </a:defRPr>
             </a:pPr>
             <a:r>
-              <a:t>→</a:t>
-            </a:r>
-          </a:p>
-        </p:txBody>
-      </p:sp>
-      <p:sp>
-        <p:nvSpPr>
-          <p:cNvPr id="11" name="Rounded Rectangle 10"/>
+              <a:t>Using tools to execute actions</a:t>
+            </a:r>
+          </a:p>
+        </p:txBody>
+      </p:sp>
+      <p:sp>
+        <p:nvSpPr>
+          <p:cNvPr id="15" name="Rounded Rectangle 14"/>
           <p:cNvSpPr/>
           <p:nvPr/>
         </p:nvSpPr>
         <p:spPr>
           <a:xfrm>
-            <a:off x="4572000" y="3840480"/>
-            <a:ext cx="1371600" cy="548640"/>
+            <a:off x="640080" y="4297680"/>
+            <a:ext cx="4663440" cy="777240"/>
           </a:xfrm>
           <a:prstGeom prst="roundRect">
+            <a:avLst/>
+          </a:prstGeom>
+          <a:solidFill>
+            <a:srgbClr val="1B2838"/>
+          </a:solidFill>
+          <a:ln>
+            <a:noFill/>
+          </a:ln>
+        </p:spPr>
+        <p:style>
+          <a:lnRef idx="1">
+            <a:schemeClr val="accent1"/>
+          </a:lnRef>
+          <a:fillRef idx="3">
+            <a:schemeClr val="accent1"/>
+          </a:fillRef>
+          <a:effectRef idx="2">
+            <a:schemeClr val="accent1"/>
+          </a:effectRef>
+          <a:fontRef idx="minor">
+            <a:schemeClr val="lt1"/>
+          </a:fontRef>
+        </p:style>
+        <p:txBody>
+          <a:bodyPr rtlCol="0" anchor="ctr"/>
+          <a:lstStyle/>
+          <a:p>
+            <a:pPr algn="ctr"/>
+          </a:p>
+        </p:txBody>
+      </p:sp>
+      <p:sp>
+        <p:nvSpPr>
+          <p:cNvPr id="16" name="Rectangle 15"/>
+          <p:cNvSpPr/>
+          <p:nvPr/>
+        </p:nvSpPr>
+        <p:spPr>
+          <a:xfrm>
+            <a:off x="640080" y="4297680"/>
+            <a:ext cx="54864" cy="777240"/>
+          </a:xfrm>
+          <a:prstGeom prst="rect">
             <a:avLst/>
           </a:prstGeom>
           <a:solidFill>
@@ -6737,64 +6903,64 @@
       </p:sp>
       <p:sp>
         <p:nvSpPr>
-          <p:cNvPr id="12" name="TextBox 11"/>
-          <p:cNvSpPr txBox="1"/>
-          <p:nvPr/>
-        </p:nvSpPr>
-        <p:spPr>
-          <a:xfrm>
-            <a:off x="4572000" y="3886200"/>
-            <a:ext cx="1371600" cy="457200"/>
-          </a:xfrm>
-          <a:prstGeom prst="rect">
-            <a:avLst/>
-          </a:prstGeom>
-          <a:noFill/>
-        </p:spPr>
-        <p:txBody>
-          <a:bodyPr wrap="square">
-            <a:spAutoFit/>
-          </a:bodyPr>
-          <a:lstStyle/>
-          <a:p>
-            <a:pPr algn="ctr">
-              <a:defRPr sz="1400" b="1">
-                <a:solidFill>
-                  <a:srgbClr val="FFFFFF"/>
-                </a:solidFill>
-                <a:latin typeface="Segoe UI"/>
-              </a:defRPr>
-            </a:pPr>
-            <a:r>
-              <a:t>Reason</a:t>
-            </a:r>
-          </a:p>
-        </p:txBody>
-      </p:sp>
-      <p:sp>
-        <p:nvSpPr>
-          <p:cNvPr id="13" name="TextBox 12"/>
-          <p:cNvSpPr txBox="1"/>
-          <p:nvPr/>
-        </p:nvSpPr>
-        <p:spPr>
-          <a:xfrm>
-            <a:off x="5943600" y="3886200"/>
-            <a:ext cx="365760" cy="457200"/>
-          </a:xfrm>
-          <a:prstGeom prst="rect">
-            <a:avLst/>
-          </a:prstGeom>
-          <a:noFill/>
-        </p:spPr>
-        <p:txBody>
-          <a:bodyPr wrap="square">
-            <a:spAutoFit/>
-          </a:bodyPr>
-          <a:lstStyle/>
-          <a:p>
-            <a:pPr algn="ctr">
-              <a:defRPr sz="2000" b="0">
+          <p:cNvPr id="17" name="TextBox 16"/>
+          <p:cNvSpPr txBox="1"/>
+          <p:nvPr/>
+        </p:nvSpPr>
+        <p:spPr>
+          <a:xfrm>
+            <a:off x="868680" y="4370832"/>
+            <a:ext cx="4297680" cy="320040"/>
+          </a:xfrm>
+          <a:prstGeom prst="rect">
+            <a:avLst/>
+          </a:prstGeom>
+          <a:noFill/>
+        </p:spPr>
+        <p:txBody>
+          <a:bodyPr wrap="square">
+            <a:spAutoFit/>
+          </a:bodyPr>
+          <a:lstStyle/>
+          <a:p>
+            <a:pPr algn="l">
+              <a:defRPr sz="1600" b="1">
+                <a:solidFill>
+                  <a:srgbClr val="8764B8"/>
+                </a:solidFill>
+                <a:latin typeface="Segoe UI"/>
+              </a:defRPr>
+            </a:pPr>
+            <a:r>
+              <a:t>iii)  Context and memory</a:t>
+            </a:r>
+          </a:p>
+        </p:txBody>
+      </p:sp>
+      <p:sp>
+        <p:nvSpPr>
+          <p:cNvPr id="18" name="TextBox 17"/>
+          <p:cNvSpPr txBox="1"/>
+          <p:nvPr/>
+        </p:nvSpPr>
+        <p:spPr>
+          <a:xfrm>
+            <a:off x="868680" y="4709160"/>
+            <a:ext cx="4297680" cy="320040"/>
+          </a:xfrm>
+          <a:prstGeom prst="rect">
+            <a:avLst/>
+          </a:prstGeom>
+          <a:noFill/>
+        </p:spPr>
+        <p:txBody>
+          <a:bodyPr wrap="square">
+            <a:spAutoFit/>
+          </a:bodyPr>
+          <a:lstStyle/>
+          <a:p>
+            <a:pPr algn="l">
+              <a:defRPr sz="1300" b="0">
                 <a:solidFill>
                   <a:srgbClr val="B0BEC5"/>
                 </a:solidFill>
@@ -6802,23 +6968,576 @@
               </a:defRPr>
             </a:pPr>
             <a:r>
-              <a:t>→</a:t>
-            </a:r>
-          </a:p>
-        </p:txBody>
-      </p:sp>
-      <p:sp>
-        <p:nvSpPr>
-          <p:cNvPr id="14" name="Rounded Rectangle 13"/>
+              <a:t>Retaining knowledge across interactions</a:t>
+            </a:r>
+          </a:p>
+        </p:txBody>
+      </p:sp>
+      <p:sp>
+        <p:nvSpPr>
+          <p:cNvPr id="19" name="TextBox 18"/>
+          <p:cNvSpPr txBox="1"/>
+          <p:nvPr/>
+        </p:nvSpPr>
+        <p:spPr>
+          <a:xfrm>
+            <a:off x="6217920" y="1371600"/>
+            <a:ext cx="5029200" cy="457200"/>
+          </a:xfrm>
+          <a:prstGeom prst="rect">
+            <a:avLst/>
+          </a:prstGeom>
+          <a:noFill/>
+        </p:spPr>
+        <p:txBody>
+          <a:bodyPr wrap="square">
+            <a:spAutoFit/>
+          </a:bodyPr>
+          <a:lstStyle/>
+          <a:p>
+            <a:pPr algn="l">
+              <a:defRPr sz="2000" b="1">
+                <a:solidFill>
+                  <a:srgbClr val="FFB900"/>
+                </a:solidFill>
+                <a:latin typeface="Segoe UI"/>
+              </a:defRPr>
+            </a:pPr>
+            <a:r>
+              <a:t>Examples of AI agents</a:t>
+            </a:r>
+          </a:p>
+        </p:txBody>
+      </p:sp>
+      <p:sp>
+        <p:nvSpPr>
+          <p:cNvPr id="20" name="Rounded Rectangle 19"/>
           <p:cNvSpPr/>
           <p:nvPr/>
         </p:nvSpPr>
         <p:spPr>
           <a:xfrm>
-            <a:off x="6309359" y="3840480"/>
-            <a:ext cx="1371600" cy="548640"/>
+            <a:off x="6400800" y="1920240"/>
+            <a:ext cx="4846320" cy="640080"/>
           </a:xfrm>
           <a:prstGeom prst="roundRect">
+            <a:avLst/>
+          </a:prstGeom>
+          <a:solidFill>
+            <a:srgbClr val="1B2838"/>
+          </a:solidFill>
+          <a:ln>
+            <a:noFill/>
+          </a:ln>
+        </p:spPr>
+        <p:style>
+          <a:lnRef idx="1">
+            <a:schemeClr val="accent1"/>
+          </a:lnRef>
+          <a:fillRef idx="3">
+            <a:schemeClr val="accent1"/>
+          </a:fillRef>
+          <a:effectRef idx="2">
+            <a:schemeClr val="accent1"/>
+          </a:effectRef>
+          <a:fontRef idx="minor">
+            <a:schemeClr val="lt1"/>
+          </a:fontRef>
+        </p:style>
+        <p:txBody>
+          <a:bodyPr rtlCol="0" anchor="ctr"/>
+          <a:lstStyle/>
+          <a:p>
+            <a:pPr algn="ctr"/>
+          </a:p>
+        </p:txBody>
+      </p:sp>
+      <p:sp>
+        <p:nvSpPr>
+          <p:cNvPr id="21" name="Rectangle 20"/>
+          <p:cNvSpPr/>
+          <p:nvPr/>
+        </p:nvSpPr>
+        <p:spPr>
+          <a:xfrm>
+            <a:off x="6400800" y="1920240"/>
+            <a:ext cx="54864" cy="640080"/>
+          </a:xfrm>
+          <a:prstGeom prst="rect">
+            <a:avLst/>
+          </a:prstGeom>
+          <a:solidFill>
+            <a:srgbClr val="0F6CBD"/>
+          </a:solidFill>
+          <a:ln>
+            <a:noFill/>
+          </a:ln>
+        </p:spPr>
+        <p:style>
+          <a:lnRef idx="1">
+            <a:schemeClr val="accent1"/>
+          </a:lnRef>
+          <a:fillRef idx="3">
+            <a:schemeClr val="accent1"/>
+          </a:fillRef>
+          <a:effectRef idx="2">
+            <a:schemeClr val="accent1"/>
+          </a:effectRef>
+          <a:fontRef idx="minor">
+            <a:schemeClr val="lt1"/>
+          </a:fontRef>
+        </p:style>
+        <p:txBody>
+          <a:bodyPr rtlCol="0" anchor="ctr"/>
+          <a:lstStyle/>
+          <a:p>
+            <a:pPr algn="ctr"/>
+          </a:p>
+        </p:txBody>
+      </p:sp>
+      <p:sp>
+        <p:nvSpPr>
+          <p:cNvPr id="22" name="TextBox 21"/>
+          <p:cNvSpPr txBox="1"/>
+          <p:nvPr/>
+        </p:nvSpPr>
+        <p:spPr>
+          <a:xfrm>
+            <a:off x="6629400" y="1965960"/>
+            <a:ext cx="4389120" cy="274320"/>
+          </a:xfrm>
+          <a:prstGeom prst="rect">
+            <a:avLst/>
+          </a:prstGeom>
+          <a:noFill/>
+        </p:spPr>
+        <p:txBody>
+          <a:bodyPr wrap="square">
+            <a:spAutoFit/>
+          </a:bodyPr>
+          <a:lstStyle/>
+          <a:p>
+            <a:pPr algn="l">
+              <a:defRPr sz="1500" b="1">
+                <a:solidFill>
+                  <a:srgbClr val="0F6CBD"/>
+                </a:solidFill>
+                <a:latin typeface="Segoe UI"/>
+              </a:defRPr>
+            </a:pPr>
+            <a:r>
+              <a:t>Coding Agent</a:t>
+            </a:r>
+          </a:p>
+        </p:txBody>
+      </p:sp>
+      <p:sp>
+        <p:nvSpPr>
+          <p:cNvPr id="23" name="TextBox 22"/>
+          <p:cNvSpPr txBox="1"/>
+          <p:nvPr/>
+        </p:nvSpPr>
+        <p:spPr>
+          <a:xfrm>
+            <a:off x="6629400" y="2240280"/>
+            <a:ext cx="4389120" cy="274320"/>
+          </a:xfrm>
+          <a:prstGeom prst="rect">
+            <a:avLst/>
+          </a:prstGeom>
+          <a:noFill/>
+        </p:spPr>
+        <p:txBody>
+          <a:bodyPr wrap="square">
+            <a:spAutoFit/>
+          </a:bodyPr>
+          <a:lstStyle/>
+          <a:p>
+            <a:pPr algn="l">
+              <a:defRPr sz="1200" b="0">
+                <a:solidFill>
+                  <a:srgbClr val="B0BEC5"/>
+                </a:solidFill>
+                <a:latin typeface="Segoe UI"/>
+              </a:defRPr>
+            </a:pPr>
+            <a:r>
+              <a:t>Writes, tests, and deploys code</a:t>
+            </a:r>
+          </a:p>
+        </p:txBody>
+      </p:sp>
+      <p:sp>
+        <p:nvSpPr>
+          <p:cNvPr id="24" name="Rounded Rectangle 23"/>
+          <p:cNvSpPr/>
+          <p:nvPr/>
+        </p:nvSpPr>
+        <p:spPr>
+          <a:xfrm>
+            <a:off x="6400800" y="2697480"/>
+            <a:ext cx="4846320" cy="640080"/>
+          </a:xfrm>
+          <a:prstGeom prst="roundRect">
+            <a:avLst/>
+          </a:prstGeom>
+          <a:solidFill>
+            <a:srgbClr val="1B2838"/>
+          </a:solidFill>
+          <a:ln>
+            <a:noFill/>
+          </a:ln>
+        </p:spPr>
+        <p:style>
+          <a:lnRef idx="1">
+            <a:schemeClr val="accent1"/>
+          </a:lnRef>
+          <a:fillRef idx="3">
+            <a:schemeClr val="accent1"/>
+          </a:fillRef>
+          <a:effectRef idx="2">
+            <a:schemeClr val="accent1"/>
+          </a:effectRef>
+          <a:fontRef idx="minor">
+            <a:schemeClr val="lt1"/>
+          </a:fontRef>
+        </p:style>
+        <p:txBody>
+          <a:bodyPr rtlCol="0" anchor="ctr"/>
+          <a:lstStyle/>
+          <a:p>
+            <a:pPr algn="ctr"/>
+          </a:p>
+        </p:txBody>
+      </p:sp>
+      <p:sp>
+        <p:nvSpPr>
+          <p:cNvPr id="25" name="Rectangle 24"/>
+          <p:cNvSpPr/>
+          <p:nvPr/>
+        </p:nvSpPr>
+        <p:spPr>
+          <a:xfrm>
+            <a:off x="6400800" y="2697480"/>
+            <a:ext cx="54864" cy="640080"/>
+          </a:xfrm>
+          <a:prstGeom prst="rect">
+            <a:avLst/>
+          </a:prstGeom>
+          <a:solidFill>
+            <a:srgbClr val="00B7C3"/>
+          </a:solidFill>
+          <a:ln>
+            <a:noFill/>
+          </a:ln>
+        </p:spPr>
+        <p:style>
+          <a:lnRef idx="1">
+            <a:schemeClr val="accent1"/>
+          </a:lnRef>
+          <a:fillRef idx="3">
+            <a:schemeClr val="accent1"/>
+          </a:fillRef>
+          <a:effectRef idx="2">
+            <a:schemeClr val="accent1"/>
+          </a:effectRef>
+          <a:fontRef idx="minor">
+            <a:schemeClr val="lt1"/>
+          </a:fontRef>
+        </p:style>
+        <p:txBody>
+          <a:bodyPr rtlCol="0" anchor="ctr"/>
+          <a:lstStyle/>
+          <a:p>
+            <a:pPr algn="ctr"/>
+          </a:p>
+        </p:txBody>
+      </p:sp>
+      <p:sp>
+        <p:nvSpPr>
+          <p:cNvPr id="26" name="TextBox 25"/>
+          <p:cNvSpPr txBox="1"/>
+          <p:nvPr/>
+        </p:nvSpPr>
+        <p:spPr>
+          <a:xfrm>
+            <a:off x="6629400" y="2743200"/>
+            <a:ext cx="4389120" cy="274320"/>
+          </a:xfrm>
+          <a:prstGeom prst="rect">
+            <a:avLst/>
+          </a:prstGeom>
+          <a:noFill/>
+        </p:spPr>
+        <p:txBody>
+          <a:bodyPr wrap="square">
+            <a:spAutoFit/>
+          </a:bodyPr>
+          <a:lstStyle/>
+          <a:p>
+            <a:pPr algn="l">
+              <a:defRPr sz="1500" b="1">
+                <a:solidFill>
+                  <a:srgbClr val="00B7C3"/>
+                </a:solidFill>
+                <a:latin typeface="Segoe UI"/>
+              </a:defRPr>
+            </a:pPr>
+            <a:r>
+              <a:t>Research Agent</a:t>
+            </a:r>
+          </a:p>
+        </p:txBody>
+      </p:sp>
+      <p:sp>
+        <p:nvSpPr>
+          <p:cNvPr id="27" name="TextBox 26"/>
+          <p:cNvSpPr txBox="1"/>
+          <p:nvPr/>
+        </p:nvSpPr>
+        <p:spPr>
+          <a:xfrm>
+            <a:off x="6629400" y="3017520"/>
+            <a:ext cx="4389120" cy="274320"/>
+          </a:xfrm>
+          <a:prstGeom prst="rect">
+            <a:avLst/>
+          </a:prstGeom>
+          <a:noFill/>
+        </p:spPr>
+        <p:txBody>
+          <a:bodyPr wrap="square">
+            <a:spAutoFit/>
+          </a:bodyPr>
+          <a:lstStyle/>
+          <a:p>
+            <a:pPr algn="l">
+              <a:defRPr sz="1200" b="0">
+                <a:solidFill>
+                  <a:srgbClr val="B0BEC5"/>
+                </a:solidFill>
+                <a:latin typeface="Segoe UI"/>
+              </a:defRPr>
+            </a:pPr>
+            <a:r>
+              <a:t>Finds, synthesizes, and summarizes information</a:t>
+            </a:r>
+          </a:p>
+        </p:txBody>
+      </p:sp>
+      <p:sp>
+        <p:nvSpPr>
+          <p:cNvPr id="28" name="Rounded Rectangle 27"/>
+          <p:cNvSpPr/>
+          <p:nvPr/>
+        </p:nvSpPr>
+        <p:spPr>
+          <a:xfrm>
+            <a:off x="6400800" y="3474720"/>
+            <a:ext cx="4846320" cy="640080"/>
+          </a:xfrm>
+          <a:prstGeom prst="roundRect">
+            <a:avLst/>
+          </a:prstGeom>
+          <a:solidFill>
+            <a:srgbClr val="1B2838"/>
+          </a:solidFill>
+          <a:ln>
+            <a:noFill/>
+          </a:ln>
+        </p:spPr>
+        <p:style>
+          <a:lnRef idx="1">
+            <a:schemeClr val="accent1"/>
+          </a:lnRef>
+          <a:fillRef idx="3">
+            <a:schemeClr val="accent1"/>
+          </a:fillRef>
+          <a:effectRef idx="2">
+            <a:schemeClr val="accent1"/>
+          </a:effectRef>
+          <a:fontRef idx="minor">
+            <a:schemeClr val="lt1"/>
+          </a:fontRef>
+        </p:style>
+        <p:txBody>
+          <a:bodyPr rtlCol="0" anchor="ctr"/>
+          <a:lstStyle/>
+          <a:p>
+            <a:pPr algn="ctr"/>
+          </a:p>
+        </p:txBody>
+      </p:sp>
+      <p:sp>
+        <p:nvSpPr>
+          <p:cNvPr id="29" name="Rectangle 28"/>
+          <p:cNvSpPr/>
+          <p:nvPr/>
+        </p:nvSpPr>
+        <p:spPr>
+          <a:xfrm>
+            <a:off x="6400800" y="3474720"/>
+            <a:ext cx="54864" cy="640080"/>
+          </a:xfrm>
+          <a:prstGeom prst="rect">
+            <a:avLst/>
+          </a:prstGeom>
+          <a:solidFill>
+            <a:srgbClr val="8764B8"/>
+          </a:solidFill>
+          <a:ln>
+            <a:noFill/>
+          </a:ln>
+        </p:spPr>
+        <p:style>
+          <a:lnRef idx="1">
+            <a:schemeClr val="accent1"/>
+          </a:lnRef>
+          <a:fillRef idx="3">
+            <a:schemeClr val="accent1"/>
+          </a:fillRef>
+          <a:effectRef idx="2">
+            <a:schemeClr val="accent1"/>
+          </a:effectRef>
+          <a:fontRef idx="minor">
+            <a:schemeClr val="lt1"/>
+          </a:fontRef>
+        </p:style>
+        <p:txBody>
+          <a:bodyPr rtlCol="0" anchor="ctr"/>
+          <a:lstStyle/>
+          <a:p>
+            <a:pPr algn="ctr"/>
+          </a:p>
+        </p:txBody>
+      </p:sp>
+      <p:sp>
+        <p:nvSpPr>
+          <p:cNvPr id="30" name="TextBox 29"/>
+          <p:cNvSpPr txBox="1"/>
+          <p:nvPr/>
+        </p:nvSpPr>
+        <p:spPr>
+          <a:xfrm>
+            <a:off x="6629400" y="3520439"/>
+            <a:ext cx="4389120" cy="274320"/>
+          </a:xfrm>
+          <a:prstGeom prst="rect">
+            <a:avLst/>
+          </a:prstGeom>
+          <a:noFill/>
+        </p:spPr>
+        <p:txBody>
+          <a:bodyPr wrap="square">
+            <a:spAutoFit/>
+          </a:bodyPr>
+          <a:lstStyle/>
+          <a:p>
+            <a:pPr algn="l">
+              <a:defRPr sz="1500" b="1">
+                <a:solidFill>
+                  <a:srgbClr val="8764B8"/>
+                </a:solidFill>
+                <a:latin typeface="Segoe UI"/>
+              </a:defRPr>
+            </a:pPr>
+            <a:r>
+              <a:t>Customer Service Agent</a:t>
+            </a:r>
+          </a:p>
+        </p:txBody>
+      </p:sp>
+      <p:sp>
+        <p:nvSpPr>
+          <p:cNvPr id="31" name="TextBox 30"/>
+          <p:cNvSpPr txBox="1"/>
+          <p:nvPr/>
+        </p:nvSpPr>
+        <p:spPr>
+          <a:xfrm>
+            <a:off x="6629400" y="3794759"/>
+            <a:ext cx="4389120" cy="274320"/>
+          </a:xfrm>
+          <a:prstGeom prst="rect">
+            <a:avLst/>
+          </a:prstGeom>
+          <a:noFill/>
+        </p:spPr>
+        <p:txBody>
+          <a:bodyPr wrap="square">
+            <a:spAutoFit/>
+          </a:bodyPr>
+          <a:lstStyle/>
+          <a:p>
+            <a:pPr algn="l">
+              <a:defRPr sz="1200" b="0">
+                <a:solidFill>
+                  <a:srgbClr val="B0BEC5"/>
+                </a:solidFill>
+                <a:latin typeface="Segoe UI"/>
+              </a:defRPr>
+            </a:pPr>
+            <a:r>
+              <a:t>Handles queries, resolves issues 24/7</a:t>
+            </a:r>
+          </a:p>
+        </p:txBody>
+      </p:sp>
+      <p:sp>
+        <p:nvSpPr>
+          <p:cNvPr id="32" name="Rounded Rectangle 31"/>
+          <p:cNvSpPr/>
+          <p:nvPr/>
+        </p:nvSpPr>
+        <p:spPr>
+          <a:xfrm>
+            <a:off x="6400800" y="4251960"/>
+            <a:ext cx="4846320" cy="640080"/>
+          </a:xfrm>
+          <a:prstGeom prst="roundRect">
+            <a:avLst/>
+          </a:prstGeom>
+          <a:solidFill>
+            <a:srgbClr val="1B2838"/>
+          </a:solidFill>
+          <a:ln>
+            <a:noFill/>
+          </a:ln>
+        </p:spPr>
+        <p:style>
+          <a:lnRef idx="1">
+            <a:schemeClr val="accent1"/>
+          </a:lnRef>
+          <a:fillRef idx="3">
+            <a:schemeClr val="accent1"/>
+          </a:fillRef>
+          <a:effectRef idx="2">
+            <a:schemeClr val="accent1"/>
+          </a:effectRef>
+          <a:fontRef idx="minor">
+            <a:schemeClr val="lt1"/>
+          </a:fontRef>
+        </p:style>
+        <p:txBody>
+          <a:bodyPr rtlCol="0" anchor="ctr"/>
+          <a:lstStyle/>
+          <a:p>
+            <a:pPr algn="ctr"/>
+          </a:p>
+        </p:txBody>
+      </p:sp>
+      <p:sp>
+        <p:nvSpPr>
+          <p:cNvPr id="33" name="Rectangle 32"/>
+          <p:cNvSpPr/>
+          <p:nvPr/>
+        </p:nvSpPr>
+        <p:spPr>
+          <a:xfrm>
+            <a:off x="6400800" y="4251960"/>
+            <a:ext cx="54864" cy="640080"/>
+          </a:xfrm>
+          <a:prstGeom prst="rect">
             <a:avLst/>
           </a:prstGeom>
           <a:solidFill>
@@ -6852,64 +7571,64 @@
       </p:sp>
       <p:sp>
         <p:nvSpPr>
-          <p:cNvPr id="15" name="TextBox 14"/>
-          <p:cNvSpPr txBox="1"/>
-          <p:nvPr/>
-        </p:nvSpPr>
-        <p:spPr>
-          <a:xfrm>
-            <a:off x="6309359" y="3886200"/>
-            <a:ext cx="1371600" cy="457200"/>
-          </a:xfrm>
-          <a:prstGeom prst="rect">
-            <a:avLst/>
-          </a:prstGeom>
-          <a:noFill/>
-        </p:spPr>
-        <p:txBody>
-          <a:bodyPr wrap="square">
-            <a:spAutoFit/>
-          </a:bodyPr>
-          <a:lstStyle/>
-          <a:p>
-            <a:pPr algn="ctr">
-              <a:defRPr sz="1400" b="1">
-                <a:solidFill>
-                  <a:srgbClr val="FFFFFF"/>
-                </a:solidFill>
-                <a:latin typeface="Segoe UI"/>
-              </a:defRPr>
-            </a:pPr>
-            <a:r>
-              <a:t>Plan</a:t>
-            </a:r>
-          </a:p>
-        </p:txBody>
-      </p:sp>
-      <p:sp>
-        <p:nvSpPr>
-          <p:cNvPr id="16" name="TextBox 15"/>
-          <p:cNvSpPr txBox="1"/>
-          <p:nvPr/>
-        </p:nvSpPr>
-        <p:spPr>
-          <a:xfrm>
-            <a:off x="7680959" y="3886200"/>
-            <a:ext cx="365760" cy="457200"/>
-          </a:xfrm>
-          <a:prstGeom prst="rect">
-            <a:avLst/>
-          </a:prstGeom>
-          <a:noFill/>
-        </p:spPr>
-        <p:txBody>
-          <a:bodyPr wrap="square">
-            <a:spAutoFit/>
-          </a:bodyPr>
-          <a:lstStyle/>
-          <a:p>
-            <a:pPr algn="ctr">
-              <a:defRPr sz="2000" b="0">
+          <p:cNvPr id="34" name="TextBox 33"/>
+          <p:cNvSpPr txBox="1"/>
+          <p:nvPr/>
+        </p:nvSpPr>
+        <p:spPr>
+          <a:xfrm>
+            <a:off x="6629400" y="4297680"/>
+            <a:ext cx="4389120" cy="274320"/>
+          </a:xfrm>
+          <a:prstGeom prst="rect">
+            <a:avLst/>
+          </a:prstGeom>
+          <a:noFill/>
+        </p:spPr>
+        <p:txBody>
+          <a:bodyPr wrap="square">
+            <a:spAutoFit/>
+          </a:bodyPr>
+          <a:lstStyle/>
+          <a:p>
+            <a:pPr algn="l">
+              <a:defRPr sz="1500" b="1">
+                <a:solidFill>
+                  <a:srgbClr val="FFB900"/>
+                </a:solidFill>
+                <a:latin typeface="Segoe UI"/>
+              </a:defRPr>
+            </a:pPr>
+            <a:r>
+              <a:t>Data Analysis Agent</a:t>
+            </a:r>
+          </a:p>
+        </p:txBody>
+      </p:sp>
+      <p:sp>
+        <p:nvSpPr>
+          <p:cNvPr id="35" name="TextBox 34"/>
+          <p:cNvSpPr txBox="1"/>
+          <p:nvPr/>
+        </p:nvSpPr>
+        <p:spPr>
+          <a:xfrm>
+            <a:off x="6629400" y="4572000"/>
+            <a:ext cx="4389120" cy="274320"/>
+          </a:xfrm>
+          <a:prstGeom prst="rect">
+            <a:avLst/>
+          </a:prstGeom>
+          <a:noFill/>
+        </p:spPr>
+        <p:txBody>
+          <a:bodyPr wrap="square">
+            <a:spAutoFit/>
+          </a:bodyPr>
+          <a:lstStyle/>
+          <a:p>
+            <a:pPr algn="l">
+              <a:defRPr sz="1200" b="0">
                 <a:solidFill>
                   <a:srgbClr val="B0BEC5"/>
                 </a:solidFill>
@@ -6917,23 +7636,66 @@
               </a:defRPr>
             </a:pPr>
             <a:r>
-              <a:t>→</a:t>
-            </a:r>
-          </a:p>
-        </p:txBody>
-      </p:sp>
-      <p:sp>
-        <p:nvSpPr>
-          <p:cNvPr id="17" name="Rounded Rectangle 16"/>
+              <a:t>Processes data, generates insights</a:t>
+            </a:r>
+          </a:p>
+        </p:txBody>
+      </p:sp>
+      <p:sp>
+        <p:nvSpPr>
+          <p:cNvPr id="36" name="Rounded Rectangle 35"/>
           <p:cNvSpPr/>
           <p:nvPr/>
         </p:nvSpPr>
         <p:spPr>
           <a:xfrm>
-            <a:off x="8046719" y="3840480"/>
-            <a:ext cx="1371600" cy="548640"/>
+            <a:off x="6400800" y="5029200"/>
+            <a:ext cx="4846320" cy="640080"/>
           </a:xfrm>
           <a:prstGeom prst="roundRect">
+            <a:avLst/>
+          </a:prstGeom>
+          <a:solidFill>
+            <a:srgbClr val="1B2838"/>
+          </a:solidFill>
+          <a:ln>
+            <a:noFill/>
+          </a:ln>
+        </p:spPr>
+        <p:style>
+          <a:lnRef idx="1">
+            <a:schemeClr val="accent1"/>
+          </a:lnRef>
+          <a:fillRef idx="3">
+            <a:schemeClr val="accent1"/>
+          </a:fillRef>
+          <a:effectRef idx="2">
+            <a:schemeClr val="accent1"/>
+          </a:effectRef>
+          <a:fontRef idx="minor">
+            <a:schemeClr val="lt1"/>
+          </a:fontRef>
+        </p:style>
+        <p:txBody>
+          <a:bodyPr rtlCol="0" anchor="ctr"/>
+          <a:lstStyle/>
+          <a:p>
+            <a:pPr algn="ctr"/>
+          </a:p>
+        </p:txBody>
+      </p:sp>
+      <p:sp>
+        <p:nvSpPr>
+          <p:cNvPr id="37" name="Rectangle 36"/>
+          <p:cNvSpPr/>
+          <p:nvPr/>
+        </p:nvSpPr>
+        <p:spPr>
+          <a:xfrm>
+            <a:off x="6400800" y="5029200"/>
+            <a:ext cx="54864" cy="640080"/>
+          </a:xfrm>
+          <a:prstGeom prst="rect">
             <a:avLst/>
           </a:prstGeom>
           <a:solidFill>
@@ -6967,14 +7729,86 @@
       </p:sp>
       <p:sp>
         <p:nvSpPr>
-          <p:cNvPr id="18" name="TextBox 17"/>
-          <p:cNvSpPr txBox="1"/>
-          <p:nvPr/>
-        </p:nvSpPr>
-        <p:spPr>
-          <a:xfrm>
-            <a:off x="8046719" y="3886200"/>
-            <a:ext cx="1371600" cy="457200"/>
+          <p:cNvPr id="38" name="TextBox 37"/>
+          <p:cNvSpPr txBox="1"/>
+          <p:nvPr/>
+        </p:nvSpPr>
+        <p:spPr>
+          <a:xfrm>
+            <a:off x="6629400" y="5074920"/>
+            <a:ext cx="4389120" cy="274320"/>
+          </a:xfrm>
+          <a:prstGeom prst="rect">
+            <a:avLst/>
+          </a:prstGeom>
+          <a:noFill/>
+        </p:spPr>
+        <p:txBody>
+          <a:bodyPr wrap="square">
+            <a:spAutoFit/>
+          </a:bodyPr>
+          <a:lstStyle/>
+          <a:p>
+            <a:pPr algn="l">
+              <a:defRPr sz="1500" b="1">
+                <a:solidFill>
+                  <a:srgbClr val="F7630C"/>
+                </a:solidFill>
+                <a:latin typeface="Segoe UI"/>
+              </a:defRPr>
+            </a:pPr>
+            <a:r>
+              <a:t>Creative Agent</a:t>
+            </a:r>
+          </a:p>
+        </p:txBody>
+      </p:sp>
+      <p:sp>
+        <p:nvSpPr>
+          <p:cNvPr id="39" name="TextBox 38"/>
+          <p:cNvSpPr txBox="1"/>
+          <p:nvPr/>
+        </p:nvSpPr>
+        <p:spPr>
+          <a:xfrm>
+            <a:off x="6629400" y="5349240"/>
+            <a:ext cx="4389120" cy="274320"/>
+          </a:xfrm>
+          <a:prstGeom prst="rect">
+            <a:avLst/>
+          </a:prstGeom>
+          <a:noFill/>
+        </p:spPr>
+        <p:txBody>
+          <a:bodyPr wrap="square">
+            <a:spAutoFit/>
+          </a:bodyPr>
+          <a:lstStyle/>
+          <a:p>
+            <a:pPr algn="l">
+              <a:defRPr sz="1200" b="0">
+                <a:solidFill>
+                  <a:srgbClr val="B0BEC5"/>
+                </a:solidFill>
+                <a:latin typeface="Segoe UI"/>
+              </a:defRPr>
+            </a:pPr>
+            <a:r>
+              <a:t>Generates content, designs, and copy</a:t>
+            </a:r>
+          </a:p>
+        </p:txBody>
+      </p:sp>
+      <p:sp>
+        <p:nvSpPr>
+          <p:cNvPr id="40" name="TextBox 39"/>
+          <p:cNvSpPr txBox="1"/>
+          <p:nvPr/>
+        </p:nvSpPr>
+        <p:spPr>
+          <a:xfrm>
+            <a:off x="457200" y="5303520"/>
+            <a:ext cx="11277295" cy="457200"/>
           </a:xfrm>
           <a:prstGeom prst="rect">
             <a:avLst/>
@@ -6988,158 +7822,7 @@
           <a:lstStyle/>
           <a:p>
             <a:pPr algn="ctr">
-              <a:defRPr sz="1400" b="1">
-                <a:solidFill>
-                  <a:srgbClr val="FFFFFF"/>
-                </a:solidFill>
-                <a:latin typeface="Segoe UI"/>
-              </a:defRPr>
-            </a:pPr>
-            <a:r>
-              <a:t>Act</a:t>
-            </a:r>
-          </a:p>
-        </p:txBody>
-      </p:sp>
-      <p:sp>
-        <p:nvSpPr>
-          <p:cNvPr id="19" name="TextBox 18"/>
-          <p:cNvSpPr txBox="1"/>
-          <p:nvPr/>
-        </p:nvSpPr>
-        <p:spPr>
-          <a:xfrm>
-            <a:off x="9418319" y="3886200"/>
-            <a:ext cx="365760" cy="457200"/>
-          </a:xfrm>
-          <a:prstGeom prst="rect">
-            <a:avLst/>
-          </a:prstGeom>
-          <a:noFill/>
-        </p:spPr>
-        <p:txBody>
-          <a:bodyPr wrap="square">
-            <a:spAutoFit/>
-          </a:bodyPr>
-          <a:lstStyle/>
-          <a:p>
-            <a:pPr algn="ctr">
-              <a:defRPr sz="2000" b="0">
-                <a:solidFill>
-                  <a:srgbClr val="B0BEC5"/>
-                </a:solidFill>
-                <a:latin typeface="Segoe UI"/>
-              </a:defRPr>
-            </a:pPr>
-            <a:r>
-              <a:t>→</a:t>
-            </a:r>
-          </a:p>
-        </p:txBody>
-      </p:sp>
-      <p:sp>
-        <p:nvSpPr>
-          <p:cNvPr id="20" name="Rounded Rectangle 19"/>
-          <p:cNvSpPr/>
-          <p:nvPr/>
-        </p:nvSpPr>
-        <p:spPr>
-          <a:xfrm>
-            <a:off x="9784080" y="3840480"/>
-            <a:ext cx="1371600" cy="548640"/>
-          </a:xfrm>
-          <a:prstGeom prst="roundRect">
-            <a:avLst/>
-          </a:prstGeom>
-          <a:solidFill>
-            <a:srgbClr val="107C10"/>
-          </a:solidFill>
-          <a:ln>
-            <a:noFill/>
-          </a:ln>
-        </p:spPr>
-        <p:style>
-          <a:lnRef idx="1">
-            <a:schemeClr val="accent1"/>
-          </a:lnRef>
-          <a:fillRef idx="3">
-            <a:schemeClr val="accent1"/>
-          </a:fillRef>
-          <a:effectRef idx="2">
-            <a:schemeClr val="accent1"/>
-          </a:effectRef>
-          <a:fontRef idx="minor">
-            <a:schemeClr val="lt1"/>
-          </a:fontRef>
-        </p:style>
-        <p:txBody>
-          <a:bodyPr rtlCol="0" anchor="ctr"/>
-          <a:lstStyle/>
-          <a:p>
-            <a:pPr algn="ctr"/>
-          </a:p>
-        </p:txBody>
-      </p:sp>
-      <p:sp>
-        <p:nvSpPr>
-          <p:cNvPr id="21" name="TextBox 20"/>
-          <p:cNvSpPr txBox="1"/>
-          <p:nvPr/>
-        </p:nvSpPr>
-        <p:spPr>
-          <a:xfrm>
-            <a:off x="9784080" y="3886200"/>
-            <a:ext cx="1371600" cy="457200"/>
-          </a:xfrm>
-          <a:prstGeom prst="rect">
-            <a:avLst/>
-          </a:prstGeom>
-          <a:noFill/>
-        </p:spPr>
-        <p:txBody>
-          <a:bodyPr wrap="square">
-            <a:spAutoFit/>
-          </a:bodyPr>
-          <a:lstStyle/>
-          <a:p>
-            <a:pPr algn="ctr">
-              <a:defRPr sz="1400" b="1">
-                <a:solidFill>
-                  <a:srgbClr val="FFFFFF"/>
-                </a:solidFill>
-                <a:latin typeface="Segoe UI"/>
-              </a:defRPr>
-            </a:pPr>
-            <a:r>
-              <a:t>Close</a:t>
-            </a:r>
-          </a:p>
-        </p:txBody>
-      </p:sp>
-      <p:sp>
-        <p:nvSpPr>
-          <p:cNvPr id="22" name="TextBox 21"/>
-          <p:cNvSpPr txBox="1"/>
-          <p:nvPr/>
-        </p:nvSpPr>
-        <p:spPr>
-          <a:xfrm>
-            <a:off x="914400" y="4754880"/>
-            <a:ext cx="10058400" cy="457200"/>
-          </a:xfrm>
-          <a:prstGeom prst="rect">
-            <a:avLst/>
-          </a:prstGeom>
-          <a:noFill/>
-        </p:spPr>
-        <p:txBody>
-          <a:bodyPr wrap="square">
-            <a:spAutoFit/>
-          </a:bodyPr>
-          <a:lstStyle/>
-          <a:p>
-            <a:pPr algn="ctr">
-              <a:defRPr sz="1600" b="0">
+              <a:defRPr sz="1600" b="1">
                 <a:solidFill>
                   <a:srgbClr val="FFB900"/>
                 </a:solidFill>
@@ -7154,7 +7837,7 @@
       </p:sp>
       <p:pic>
         <p:nvPicPr>
-          <p:cNvPr id="23" name="Picture 22" descr="microsoft-logo.png"/>
+          <p:cNvPr id="41" name="Picture 40" descr="microsoft-logo.png"/>
           <p:cNvPicPr>
             <a:picLocks noChangeAspect="1"/>
           </p:cNvPicPr>

</xml_diff>